<commit_message>
feat: reforzar entrega de boxplots modernos
</commit_message>
<xml_diff>
--- a/presentation/presentacion_boxplots_modernos.pptx
+++ b/presentation/presentacion_boxplots_modernos.pptx
@@ -18,6 +18,7 @@
     <p:sldId id="266" r:id="rId17"/>
     <p:sldId id="267" r:id="rId18"/>
     <p:sldId id="268" r:id="rId19"/>
+    <p:sldId id="269" r:id="rId20"/>
   </p:sldIdLst>
   <p:sldSz cx="12191695" cy="6858000" type="screen4x3"/>
   <p:notesSz cx="6858000" cy="9144000"/>
@@ -3442,7 +3443,7 @@
                 </a:solidFill>
                 <a:latin typeface="Aptos"/>
               </a:rPr>
-              <a:t>Boxenplot · top 5 de cultivos</a:t>
+              <a:t>Boxenplot · cinco cultivos con más registros</a:t>
             </a:r>
           </a:p>
         </p:txBody>
@@ -4482,7 +4483,7 @@
                 </a:solidFill>
                 <a:latin typeface="Aptos"/>
               </a:rPr>
-              <a:t>En los seis departamentos la media queda por debajo de la mediana, señal de cola baja. Antioquia lidera por mediana (1,21 t/ha) y Boyacá queda al final (0,95); el IQR máximo es 0,44 t/ha.</a:t>
+              <a:t>En los seis departamentos la media es levemente menor que la mediana. Antioquia lidera por mediana (1,21 t/ha) y Boyacá queda al final (0,95); el IQR máximo es 0,44 t/ha.</a:t>
             </a:r>
           </a:p>
         </p:txBody>
@@ -5527,7 +5528,7 @@
 </p:sld>
 </file>
 
-<file path=ppt/slides/slide2.xml><?xml version="1.0" encoding="utf-8"?>
+<file path=ppt/slides/slide14.xml><?xml version="1.0" encoding="utf-8"?>
 <p:sld xmlns:a="http://schemas.openxmlformats.org/drawingml/2006/main" xmlns:p="http://schemas.openxmlformats.org/presentationml/2006/main" xmlns:r="http://schemas.openxmlformats.org/officeDocument/2006/relationships">
   <p:cSld>
     <p:spTree>
@@ -5571,7 +5572,7 @@
                 </a:solidFill>
                 <a:latin typeface="Aptos"/>
               </a:rPr>
-              <a:t>Datos, método y entregables</a:t>
+              <a:t>Reproducibilidad y fuentes</a:t>
             </a:r>
           </a:p>
         </p:txBody>
@@ -5610,7 +5611,7 @@
                 </a:solidFill>
                 <a:latin typeface="Aptos"/>
               </a:rPr>
-              <a:t>Una misma fuente abierta; cinco preguntas y cinco visualizaciones interactivas</a:t>
+              <a:t>El código y los artefactos de la entrega permiten repetir e inspeccionar el análisis</a:t>
             </a:r>
           </a:p>
         </p:txBody>
@@ -5624,7 +5625,7 @@
         <p:spPr>
           <a:xfrm>
             <a:off x="594360" y="1325880"/>
-            <a:ext cx="3520440" cy="4434840"/>
+            <a:ext cx="3520440" cy="4297680"/>
           </a:xfrm>
           <a:prstGeom prst="roundRect">
             <a:avLst/>
@@ -5694,7 +5695,7 @@
                 </a:solidFill>
                 <a:latin typeface="Aptos"/>
               </a:rPr>
-              <a:t>DATASET REAL</a:t>
+              <a:t>CÓDIGO FUNCIONAL</a:t>
             </a:r>
           </a:p>
         </p:txBody>
@@ -5708,7 +5709,7 @@
         <p:spPr>
           <a:xfrm>
             <a:off x="777240" y="1783080"/>
-            <a:ext cx="3154680" cy="3867911"/>
+            <a:ext cx="3154680" cy="3730752"/>
           </a:xfrm>
           <a:prstGeom prst="rect">
             <a:avLst/>
@@ -5733,7 +5734,7 @@
                 </a:solidFill>
                 <a:latin typeface="Aptos"/>
               </a:rPr>
-              <a:t>Evaluaciones Agropecuarias Municipales – EVA. 2019–2025, Base Agrícola (UPRA).</a:t>
+              <a:t>El cuaderno construye las figuras manualmente con np.quantile y go.Scatter.</a:t>
             </a:r>
           </a:p>
           <a:p>
@@ -5756,15 +5757,8 @@
                 </a:solidFill>
                 <a:latin typeface="Aptos"/>
               </a:rPr>
-              <a:t>166.732 registros; 32 departamentos; 1.103 municipios; 165 cultivos.</a:t>
-            </a:r>
-          </a:p>
-          <a:p>
-            <a:pPr algn="l">
-              <a:spcAft>
-                <a:spcPts val="400"/>
-              </a:spcAft>
-            </a:pPr>
+              <a:t>fig.write_html(ruta_html, include_plotlyjs=True)</a:t>
+            </a:r>
           </a:p>
           <a:p>
             <a:pPr algn="l">
@@ -5779,7 +5773,30 @@
                 </a:solidFill>
                 <a:latin typeface="Aptos"/>
               </a:rPr>
-              <a:t>Cada punto representa municipio × cultivo × período.</a:t>
+              <a:t>fig.write_image(ruta_png, scale=2)</a:t>
+            </a:r>
+          </a:p>
+          <a:p>
+            <a:pPr algn="l">
+              <a:spcAft>
+                <a:spcPts val="400"/>
+              </a:spcAft>
+            </a:pPr>
+          </a:p>
+          <a:p>
+            <a:pPr algn="l">
+              <a:spcAft>
+                <a:spcPts val="400"/>
+              </a:spcAft>
+            </a:pPr>
+            <a:r>
+              <a:rPr sz="1500" b="0">
+                <a:solidFill>
+                  <a:srgbClr val="202124"/>
+                </a:solidFill>
+                <a:latin typeface="Aptos"/>
+              </a:rPr>
+              <a:t>Los HTML son autónomos: se abren en el navegador y conservan el hover.</a:t>
             </a:r>
           </a:p>
         </p:txBody>
@@ -5793,7 +5810,7 @@
         <p:spPr>
           <a:xfrm>
             <a:off x="4334256" y="1325880"/>
-            <a:ext cx="3520440" cy="4434840"/>
+            <a:ext cx="3520440" cy="4297680"/>
           </a:xfrm>
           <a:prstGeom prst="roundRect">
             <a:avLst/>
@@ -5863,7 +5880,7 @@
                 </a:solidFill>
                 <a:latin typeface="Aptos"/>
               </a:rPr>
-              <a:t>REPRODUCIBILIDAD</a:t>
+              <a:t>ENTREGA VERIFICABLE</a:t>
             </a:r>
           </a:p>
         </p:txBody>
@@ -5877,7 +5894,7 @@
         <p:spPr>
           <a:xfrm>
             <a:off x="4517136" y="1783080"/>
-            <a:ext cx="3154680" cy="3867911"/>
+            <a:ext cx="3154680" cy="3730752"/>
           </a:xfrm>
           <a:prstGeom prst="rect">
             <a:avLst/>
@@ -5902,7 +5919,7 @@
                 </a:solidFill>
                 <a:latin typeface="Aptos"/>
               </a:rPr>
-              <a:t>Cuaderno Python: proyecto_boxplots/boxplots_modernos_EVA.ipynb.</a:t>
+              <a:t>Cuaderno: proyecto_boxplots/boxplots_modernos_EVA.ipynb.</a:t>
             </a:r>
           </a:p>
           <a:p>
@@ -5925,7 +5942,7 @@
                 </a:solidFill>
                 <a:latin typeface="Aptos"/>
               </a:rPr>
-              <a:t>Genera cinco HTML Plotly autónomos, cinco PNG y las interpretaciones.</a:t>
+              <a:t>Cinco HTML: proyecto_boxplots/figuras_interactivas/.</a:t>
             </a:r>
           </a:p>
           <a:p>
@@ -5948,7 +5965,30 @@
                 </a:solidFill>
                 <a:latin typeface="Aptos"/>
               </a:rPr>
-              <a:t>No se usaron datos simulados.</a:t>
+              <a:t>Cinco PNG y un JSON con las interpretaciones.</a:t>
+            </a:r>
+          </a:p>
+          <a:p>
+            <a:pPr algn="l">
+              <a:spcAft>
+                <a:spcPts val="400"/>
+              </a:spcAft>
+            </a:pPr>
+          </a:p>
+          <a:p>
+            <a:pPr algn="l">
+              <a:spcAft>
+                <a:spcPts val="400"/>
+              </a:spcAft>
+            </a:pPr>
+            <a:r>
+              <a:rPr sz="1500" b="0">
+                <a:solidFill>
+                  <a:srgbClr val="202124"/>
+                </a:solidFill>
+                <a:latin typeface="Aptos"/>
+              </a:rPr>
+              <a:t>El CSV original no fue modificado.</a:t>
             </a:r>
           </a:p>
         </p:txBody>
@@ -5962,7 +6002,7 @@
         <p:spPr>
           <a:xfrm>
             <a:off x="8074152" y="1325880"/>
-            <a:ext cx="3520440" cy="4434840"/>
+            <a:ext cx="3520440" cy="4297680"/>
           </a:xfrm>
           <a:prstGeom prst="roundRect">
             <a:avLst/>
@@ -6032,6 +6072,847 @@
                 </a:solidFill>
                 <a:latin typeface="Aptos"/>
               </a:rPr>
+              <a:t>REFERENCIAS</a:t>
+            </a:r>
+          </a:p>
+        </p:txBody>
+      </p:sp>
+      <p:sp>
+        <p:nvSpPr>
+          <p:cNvPr id="12" name="TextBox 11"/>
+          <p:cNvSpPr txBox="1"/>
+          <p:nvPr/>
+        </p:nvSpPr>
+        <p:spPr>
+          <a:xfrm>
+            <a:off x="8257031" y="1783080"/>
+            <a:ext cx="3154680" cy="3730752"/>
+          </a:xfrm>
+          <a:prstGeom prst="rect">
+            <a:avLst/>
+          </a:prstGeom>
+          <a:noFill/>
+        </p:spPr>
+        <p:txBody>
+          <a:bodyPr wrap="square" anchor="t">
+            <a:spAutoFit/>
+          </a:bodyPr>
+          <a:lstStyle/>
+          <a:p>
+            <a:pPr algn="l">
+              <a:spcAft>
+                <a:spcPts val="400"/>
+              </a:spcAft>
+            </a:pPr>
+            <a:r>
+              <a:rPr sz="1500" b="0">
+                <a:solidFill>
+                  <a:srgbClr val="202124"/>
+                </a:solidFill>
+                <a:latin typeface="Aptos"/>
+              </a:rPr>
+              <a:t>Fuente primaria: EVA 2019–2025, UPRA.</a:t>
+            </a:r>
+          </a:p>
+          <a:p>
+            <a:pPr algn="l">
+              <a:spcAft>
+                <a:spcPts val="400"/>
+              </a:spcAft>
+            </a:pPr>
+          </a:p>
+          <a:p>
+            <a:pPr algn="l">
+              <a:spcAft>
+                <a:spcPts val="400"/>
+              </a:spcAft>
+            </a:pPr>
+            <a:r>
+              <a:rPr sz="1500" b="0">
+                <a:solidFill>
+                  <a:srgbClr val="202124"/>
+                </a:solidFill>
+                <a:latin typeface="Aptos"/>
+              </a:rPr>
+              <a:t>Guía de diseño: Clase 8, Análisis de datos.</a:t>
+            </a:r>
+          </a:p>
+          <a:p>
+            <a:pPr algn="l">
+              <a:spcAft>
+                <a:spcPts val="400"/>
+              </a:spcAft>
+            </a:pPr>
+          </a:p>
+          <a:p>
+            <a:pPr algn="l">
+              <a:spcAft>
+                <a:spcPts val="400"/>
+              </a:spcAft>
+            </a:pPr>
+            <a:r>
+              <a:rPr sz="1500" b="0">
+                <a:solidFill>
+                  <a:srgbClr val="202124"/>
+                </a:solidFill>
+                <a:latin typeface="Aptos"/>
+              </a:rPr>
+              <a:t>Implementación: documentación de Plotly para Python.</a:t>
+            </a:r>
+          </a:p>
+        </p:txBody>
+      </p:sp>
+      <p:sp>
+        <p:nvSpPr>
+          <p:cNvPr id="13" name="TextBox 12"/>
+          <p:cNvSpPr txBox="1"/>
+          <p:nvPr/>
+        </p:nvSpPr>
+        <p:spPr>
+          <a:xfrm>
+            <a:off x="8275320" y="4617720"/>
+            <a:ext cx="3108960" cy="256032"/>
+          </a:xfrm>
+          <a:prstGeom prst="rect">
+            <a:avLst/>
+          </a:prstGeom>
+          <a:noFill/>
+        </p:spPr>
+        <p:txBody>
+          <a:bodyPr wrap="square" anchor="t">
+            <a:spAutoFit/>
+          </a:bodyPr>
+          <a:lstStyle/>
+          <a:p>
+            <a:pPr algn="l">
+              <a:spcAft>
+                <a:spcPts val="400"/>
+              </a:spcAft>
+            </a:pPr>
+            <a:r>
+              <a:rPr sz="1000" b="0">
+                <a:solidFill>
+                  <a:srgbClr val="0B5394"/>
+                </a:solidFill>
+                <a:latin typeface="Aptos"/>
+                <a:hlinkClick r:id="rId2"/>
+              </a:rPr>
+              <a:t>datos.gov.co/d/uejq-wxrr</a:t>
+            </a:r>
+          </a:p>
+        </p:txBody>
+      </p:sp>
+      <p:sp>
+        <p:nvSpPr>
+          <p:cNvPr id="14" name="TextBox 13"/>
+          <p:cNvSpPr txBox="1"/>
+          <p:nvPr/>
+        </p:nvSpPr>
+        <p:spPr>
+          <a:xfrm>
+            <a:off x="8275320" y="4919472"/>
+            <a:ext cx="3108960" cy="256032"/>
+          </a:xfrm>
+          <a:prstGeom prst="rect">
+            <a:avLst/>
+          </a:prstGeom>
+          <a:noFill/>
+        </p:spPr>
+        <p:txBody>
+          <a:bodyPr wrap="square" anchor="t">
+            <a:spAutoFit/>
+          </a:bodyPr>
+          <a:lstStyle/>
+          <a:p>
+            <a:pPr algn="l">
+              <a:spcAft>
+                <a:spcPts val="400"/>
+              </a:spcAft>
+            </a:pPr>
+            <a:r>
+              <a:rPr sz="1000" b="0">
+                <a:solidFill>
+                  <a:srgbClr val="0B5394"/>
+                </a:solidFill>
+                <a:latin typeface="Aptos"/>
+                <a:hlinkClick r:id="rId3"/>
+              </a:rPr>
+              <a:t>github.com/juliangarzon/.../clase08</a:t>
+            </a:r>
+          </a:p>
+        </p:txBody>
+      </p:sp>
+      <p:sp>
+        <p:nvSpPr>
+          <p:cNvPr id="15" name="TextBox 14"/>
+          <p:cNvSpPr txBox="1"/>
+          <p:nvPr/>
+        </p:nvSpPr>
+        <p:spPr>
+          <a:xfrm>
+            <a:off x="8275320" y="5221224"/>
+            <a:ext cx="3108960" cy="256032"/>
+          </a:xfrm>
+          <a:prstGeom prst="rect">
+            <a:avLst/>
+          </a:prstGeom>
+          <a:noFill/>
+        </p:spPr>
+        <p:txBody>
+          <a:bodyPr wrap="square" anchor="t">
+            <a:spAutoFit/>
+          </a:bodyPr>
+          <a:lstStyle/>
+          <a:p>
+            <a:pPr algn="l">
+              <a:spcAft>
+                <a:spcPts val="400"/>
+              </a:spcAft>
+            </a:pPr>
+            <a:r>
+              <a:rPr sz="1000" b="0">
+                <a:solidFill>
+                  <a:srgbClr val="0B5394"/>
+                </a:solidFill>
+                <a:latin typeface="Aptos"/>
+                <a:hlinkClick r:id="rId4"/>
+              </a:rPr>
+              <a:t>plotly.com/python/</a:t>
+            </a:r>
+          </a:p>
+        </p:txBody>
+      </p:sp>
+      <p:sp>
+        <p:nvSpPr>
+          <p:cNvPr id="16" name="TextBox 15"/>
+          <p:cNvSpPr txBox="1"/>
+          <p:nvPr/>
+        </p:nvSpPr>
+        <p:spPr>
+          <a:xfrm>
+            <a:off x="594360" y="6492240"/>
+            <a:ext cx="7315200" cy="201168"/>
+          </a:xfrm>
+          <a:prstGeom prst="rect">
+            <a:avLst/>
+          </a:prstGeom>
+          <a:noFill/>
+        </p:spPr>
+        <p:txBody>
+          <a:bodyPr wrap="square" anchor="t">
+            <a:spAutoFit/>
+          </a:bodyPr>
+          <a:lstStyle/>
+          <a:p>
+            <a:pPr algn="l">
+              <a:spcAft>
+                <a:spcPts val="400"/>
+              </a:spcAft>
+            </a:pPr>
+            <a:r>
+              <a:rPr sz="900" b="0">
+                <a:solidFill>
+                  <a:srgbClr val="5A5A5A"/>
+                </a:solidFill>
+                <a:latin typeface="Aptos"/>
+              </a:rPr>
+              <a:t>Fuente: EVA 2019–2025 (UPRA) · datos.gov.co</a:t>
+            </a:r>
+          </a:p>
+        </p:txBody>
+      </p:sp>
+      <p:sp>
+        <p:nvSpPr>
+          <p:cNvPr id="17" name="TextBox 16"/>
+          <p:cNvSpPr txBox="1"/>
+          <p:nvPr/>
+        </p:nvSpPr>
+        <p:spPr>
+          <a:xfrm>
+            <a:off x="7955279" y="6492240"/>
+            <a:ext cx="3383280" cy="201168"/>
+          </a:xfrm>
+          <a:prstGeom prst="rect">
+            <a:avLst/>
+          </a:prstGeom>
+          <a:noFill/>
+        </p:spPr>
+        <p:txBody>
+          <a:bodyPr wrap="square" anchor="t">
+            <a:spAutoFit/>
+          </a:bodyPr>
+          <a:lstStyle/>
+          <a:p>
+            <a:pPr algn="r">
+              <a:spcAft>
+                <a:spcPts val="400"/>
+              </a:spcAft>
+            </a:pPr>
+            <a:r>
+              <a:rPr sz="900" b="0">
+                <a:solidFill>
+                  <a:srgbClr val="0B5394"/>
+                </a:solidFill>
+                <a:latin typeface="Aptos"/>
+                <a:hlinkClick r:id="rId2"/>
+              </a:rPr>
+              <a:t>https://www.datos.gov.co/d/uejq-wxrr</a:t>
+            </a:r>
+          </a:p>
+        </p:txBody>
+      </p:sp>
+      <p:sp>
+        <p:nvSpPr>
+          <p:cNvPr id="18" name="TextBox 17"/>
+          <p:cNvSpPr txBox="1"/>
+          <p:nvPr/>
+        </p:nvSpPr>
+        <p:spPr>
+          <a:xfrm>
+            <a:off x="11384280" y="6492240"/>
+            <a:ext cx="228600" cy="201168"/>
+          </a:xfrm>
+          <a:prstGeom prst="rect">
+            <a:avLst/>
+          </a:prstGeom>
+          <a:noFill/>
+        </p:spPr>
+        <p:txBody>
+          <a:bodyPr wrap="square" anchor="t">
+            <a:spAutoFit/>
+          </a:bodyPr>
+          <a:lstStyle/>
+          <a:p>
+            <a:pPr algn="r">
+              <a:spcAft>
+                <a:spcPts val="400"/>
+              </a:spcAft>
+            </a:pPr>
+            <a:r>
+              <a:rPr sz="900" b="0">
+                <a:solidFill>
+                  <a:srgbClr val="5A5A5A"/>
+                </a:solidFill>
+                <a:latin typeface="Aptos"/>
+              </a:rPr>
+              <a:t>14</a:t>
+            </a:r>
+          </a:p>
+        </p:txBody>
+      </p:sp>
+    </p:spTree>
+  </p:cSld>
+  <p:clrMapOvr>
+    <a:masterClrMapping/>
+  </p:clrMapOvr>
+</p:sld>
+</file>
+
+<file path=ppt/slides/slide2.xml><?xml version="1.0" encoding="utf-8"?>
+<p:sld xmlns:a="http://schemas.openxmlformats.org/drawingml/2006/main" xmlns:p="http://schemas.openxmlformats.org/presentationml/2006/main" xmlns:r="http://schemas.openxmlformats.org/officeDocument/2006/relationships">
+  <p:cSld>
+    <p:spTree>
+      <p:nvGrpSpPr>
+        <p:cNvPr id="1" name=""/>
+        <p:cNvGrpSpPr/>
+        <p:nvPr/>
+      </p:nvGrpSpPr>
+      <p:grpSpPr/>
+      <p:sp>
+        <p:nvSpPr>
+          <p:cNvPr id="2" name="TextBox 1"/>
+          <p:cNvSpPr txBox="1"/>
+          <p:nvPr/>
+        </p:nvSpPr>
+        <p:spPr>
+          <a:xfrm>
+            <a:off x="594360" y="292608"/>
+            <a:ext cx="10972800" cy="502920"/>
+          </a:xfrm>
+          <a:prstGeom prst="rect">
+            <a:avLst/>
+          </a:prstGeom>
+          <a:noFill/>
+        </p:spPr>
+        <p:txBody>
+          <a:bodyPr wrap="square" anchor="t">
+            <a:spAutoFit/>
+          </a:bodyPr>
+          <a:lstStyle/>
+          <a:p>
+            <a:pPr algn="l">
+              <a:spcAft>
+                <a:spcPts val="400"/>
+              </a:spcAft>
+            </a:pPr>
+            <a:r>
+              <a:rPr sz="2500" b="1">
+                <a:solidFill>
+                  <a:srgbClr val="0B5394"/>
+                </a:solidFill>
+                <a:latin typeface="Aptos"/>
+              </a:rPr>
+              <a:t>Datos, método y entregables</a:t>
+            </a:r>
+          </a:p>
+        </p:txBody>
+      </p:sp>
+      <p:sp>
+        <p:nvSpPr>
+          <p:cNvPr id="3" name="TextBox 2"/>
+          <p:cNvSpPr txBox="1"/>
+          <p:nvPr/>
+        </p:nvSpPr>
+        <p:spPr>
+          <a:xfrm>
+            <a:off x="621792" y="822960"/>
+            <a:ext cx="10972800" cy="274320"/>
+          </a:xfrm>
+          <a:prstGeom prst="rect">
+            <a:avLst/>
+          </a:prstGeom>
+          <a:noFill/>
+        </p:spPr>
+        <p:txBody>
+          <a:bodyPr wrap="square" anchor="t">
+            <a:spAutoFit/>
+          </a:bodyPr>
+          <a:lstStyle/>
+          <a:p>
+            <a:pPr algn="l">
+              <a:spcAft>
+                <a:spcPts val="400"/>
+              </a:spcAft>
+            </a:pPr>
+            <a:r>
+              <a:rPr sz="1100" b="0">
+                <a:solidFill>
+                  <a:srgbClr val="5A5A5A"/>
+                </a:solidFill>
+                <a:latin typeface="Aptos"/>
+              </a:rPr>
+              <a:t>Una misma fuente abierta; cinco preguntas y cinco visualizaciones interactivas</a:t>
+            </a:r>
+          </a:p>
+        </p:txBody>
+      </p:sp>
+      <p:sp>
+        <p:nvSpPr>
+          <p:cNvPr id="4" name="Rounded Rectangle 3"/>
+          <p:cNvSpPr/>
+          <p:nvPr/>
+        </p:nvSpPr>
+        <p:spPr>
+          <a:xfrm>
+            <a:off x="594360" y="1325880"/>
+            <a:ext cx="3520440" cy="4434840"/>
+          </a:xfrm>
+          <a:prstGeom prst="roundRect">
+            <a:avLst/>
+          </a:prstGeom>
+          <a:solidFill>
+            <a:srgbClr val="F2F2F2"/>
+          </a:solidFill>
+          <a:ln w="12700">
+            <a:solidFill>
+              <a:srgbClr val="0B5394"/>
+            </a:solidFill>
+          </a:ln>
+        </p:spPr>
+        <p:style>
+          <a:lnRef idx="1">
+            <a:schemeClr val="accent1"/>
+          </a:lnRef>
+          <a:fillRef idx="3">
+            <a:schemeClr val="accent1"/>
+          </a:fillRef>
+          <a:effectRef idx="2">
+            <a:schemeClr val="accent1"/>
+          </a:effectRef>
+          <a:fontRef idx="minor">
+            <a:schemeClr val="lt1"/>
+          </a:fontRef>
+        </p:style>
+        <p:txBody>
+          <a:bodyPr rtlCol="0" anchor="ctr"/>
+          <a:lstStyle/>
+          <a:p>
+            <a:pPr algn="ctr"/>
+          </a:p>
+        </p:txBody>
+      </p:sp>
+      <p:sp>
+        <p:nvSpPr>
+          <p:cNvPr id="5" name="TextBox 4"/>
+          <p:cNvSpPr txBox="1"/>
+          <p:nvPr/>
+        </p:nvSpPr>
+        <p:spPr>
+          <a:xfrm>
+            <a:off x="777240" y="1463039"/>
+            <a:ext cx="3154680" cy="292608"/>
+          </a:xfrm>
+          <a:prstGeom prst="rect">
+            <a:avLst/>
+          </a:prstGeom>
+          <a:noFill/>
+        </p:spPr>
+        <p:txBody>
+          <a:bodyPr wrap="square" anchor="t">
+            <a:spAutoFit/>
+          </a:bodyPr>
+          <a:lstStyle/>
+          <a:p>
+            <a:pPr algn="l">
+              <a:spcAft>
+                <a:spcPts val="400"/>
+              </a:spcAft>
+            </a:pPr>
+            <a:r>
+              <a:rPr sz="1000" b="1">
+                <a:solidFill>
+                  <a:srgbClr val="0B5394"/>
+                </a:solidFill>
+                <a:latin typeface="Aptos"/>
+              </a:rPr>
+              <a:t>DATASET REAL</a:t>
+            </a:r>
+          </a:p>
+        </p:txBody>
+      </p:sp>
+      <p:sp>
+        <p:nvSpPr>
+          <p:cNvPr id="6" name="TextBox 5"/>
+          <p:cNvSpPr txBox="1"/>
+          <p:nvPr/>
+        </p:nvSpPr>
+        <p:spPr>
+          <a:xfrm>
+            <a:off x="777240" y="1783080"/>
+            <a:ext cx="3154680" cy="3867911"/>
+          </a:xfrm>
+          <a:prstGeom prst="rect">
+            <a:avLst/>
+          </a:prstGeom>
+          <a:noFill/>
+        </p:spPr>
+        <p:txBody>
+          <a:bodyPr wrap="square" anchor="t">
+            <a:spAutoFit/>
+          </a:bodyPr>
+          <a:lstStyle/>
+          <a:p>
+            <a:pPr algn="l">
+              <a:spcAft>
+                <a:spcPts val="400"/>
+              </a:spcAft>
+            </a:pPr>
+            <a:r>
+              <a:rPr sz="1500" b="0">
+                <a:solidFill>
+                  <a:srgbClr val="202124"/>
+                </a:solidFill>
+                <a:latin typeface="Aptos"/>
+              </a:rPr>
+              <a:t>Evaluaciones Agropecuarias Municipales – EVA. 2019–2025, Base Agrícola (UPRA).</a:t>
+            </a:r>
+          </a:p>
+          <a:p>
+            <a:pPr algn="l">
+              <a:spcAft>
+                <a:spcPts val="400"/>
+              </a:spcAft>
+            </a:pPr>
+          </a:p>
+          <a:p>
+            <a:pPr algn="l">
+              <a:spcAft>
+                <a:spcPts val="400"/>
+              </a:spcAft>
+            </a:pPr>
+            <a:r>
+              <a:rPr sz="1500" b="0">
+                <a:solidFill>
+                  <a:srgbClr val="202124"/>
+                </a:solidFill>
+                <a:latin typeface="Aptos"/>
+              </a:rPr>
+              <a:t>166.732 registros; 32 departamentos; 1.103 municipios; 165 cultivos.</a:t>
+            </a:r>
+          </a:p>
+          <a:p>
+            <a:pPr algn="l">
+              <a:spcAft>
+                <a:spcPts val="400"/>
+              </a:spcAft>
+            </a:pPr>
+          </a:p>
+          <a:p>
+            <a:pPr algn="l">
+              <a:spcAft>
+                <a:spcPts val="400"/>
+              </a:spcAft>
+            </a:pPr>
+            <a:r>
+              <a:rPr sz="1500" b="0">
+                <a:solidFill>
+                  <a:srgbClr val="202124"/>
+                </a:solidFill>
+                <a:latin typeface="Aptos"/>
+              </a:rPr>
+              <a:t>Cada punto representa municipio × cultivo × período.</a:t>
+            </a:r>
+          </a:p>
+        </p:txBody>
+      </p:sp>
+      <p:sp>
+        <p:nvSpPr>
+          <p:cNvPr id="7" name="Rounded Rectangle 6"/>
+          <p:cNvSpPr/>
+          <p:nvPr/>
+        </p:nvSpPr>
+        <p:spPr>
+          <a:xfrm>
+            <a:off x="4334256" y="1325880"/>
+            <a:ext cx="3520440" cy="4434840"/>
+          </a:xfrm>
+          <a:prstGeom prst="roundRect">
+            <a:avLst/>
+          </a:prstGeom>
+          <a:solidFill>
+            <a:srgbClr val="F2F2F2"/>
+          </a:solidFill>
+          <a:ln w="12700">
+            <a:solidFill>
+              <a:srgbClr val="0B5394"/>
+            </a:solidFill>
+          </a:ln>
+        </p:spPr>
+        <p:style>
+          <a:lnRef idx="1">
+            <a:schemeClr val="accent1"/>
+          </a:lnRef>
+          <a:fillRef idx="3">
+            <a:schemeClr val="accent1"/>
+          </a:fillRef>
+          <a:effectRef idx="2">
+            <a:schemeClr val="accent1"/>
+          </a:effectRef>
+          <a:fontRef idx="minor">
+            <a:schemeClr val="lt1"/>
+          </a:fontRef>
+        </p:style>
+        <p:txBody>
+          <a:bodyPr rtlCol="0" anchor="ctr"/>
+          <a:lstStyle/>
+          <a:p>
+            <a:pPr algn="ctr"/>
+          </a:p>
+        </p:txBody>
+      </p:sp>
+      <p:sp>
+        <p:nvSpPr>
+          <p:cNvPr id="8" name="TextBox 7"/>
+          <p:cNvSpPr txBox="1"/>
+          <p:nvPr/>
+        </p:nvSpPr>
+        <p:spPr>
+          <a:xfrm>
+            <a:off x="4517136" y="1463039"/>
+            <a:ext cx="3154680" cy="292608"/>
+          </a:xfrm>
+          <a:prstGeom prst="rect">
+            <a:avLst/>
+          </a:prstGeom>
+          <a:noFill/>
+        </p:spPr>
+        <p:txBody>
+          <a:bodyPr wrap="square" anchor="t">
+            <a:spAutoFit/>
+          </a:bodyPr>
+          <a:lstStyle/>
+          <a:p>
+            <a:pPr algn="l">
+              <a:spcAft>
+                <a:spcPts val="400"/>
+              </a:spcAft>
+            </a:pPr>
+            <a:r>
+              <a:rPr sz="1000" b="1">
+                <a:solidFill>
+                  <a:srgbClr val="0B5394"/>
+                </a:solidFill>
+                <a:latin typeface="Aptos"/>
+              </a:rPr>
+              <a:t>REPRODUCIBILIDAD</a:t>
+            </a:r>
+          </a:p>
+        </p:txBody>
+      </p:sp>
+      <p:sp>
+        <p:nvSpPr>
+          <p:cNvPr id="9" name="TextBox 8"/>
+          <p:cNvSpPr txBox="1"/>
+          <p:nvPr/>
+        </p:nvSpPr>
+        <p:spPr>
+          <a:xfrm>
+            <a:off x="4517136" y="1783080"/>
+            <a:ext cx="3154680" cy="3867911"/>
+          </a:xfrm>
+          <a:prstGeom prst="rect">
+            <a:avLst/>
+          </a:prstGeom>
+          <a:noFill/>
+        </p:spPr>
+        <p:txBody>
+          <a:bodyPr wrap="square" anchor="t">
+            <a:spAutoFit/>
+          </a:bodyPr>
+          <a:lstStyle/>
+          <a:p>
+            <a:pPr algn="l">
+              <a:spcAft>
+                <a:spcPts val="400"/>
+              </a:spcAft>
+            </a:pPr>
+            <a:r>
+              <a:rPr sz="1500" b="0">
+                <a:solidFill>
+                  <a:srgbClr val="202124"/>
+                </a:solidFill>
+                <a:latin typeface="Aptos"/>
+              </a:rPr>
+              <a:t>Cuaderno Python: proyecto_boxplots/boxplots_modernos_EVA.ipynb.</a:t>
+            </a:r>
+          </a:p>
+          <a:p>
+            <a:pPr algn="l">
+              <a:spcAft>
+                <a:spcPts val="400"/>
+              </a:spcAft>
+            </a:pPr>
+          </a:p>
+          <a:p>
+            <a:pPr algn="l">
+              <a:spcAft>
+                <a:spcPts val="400"/>
+              </a:spcAft>
+            </a:pPr>
+            <a:r>
+              <a:rPr sz="1500" b="0">
+                <a:solidFill>
+                  <a:srgbClr val="202124"/>
+                </a:solidFill>
+                <a:latin typeface="Aptos"/>
+              </a:rPr>
+              <a:t>Genera cinco HTML Plotly autónomos, cinco PNG y las interpretaciones.</a:t>
+            </a:r>
+          </a:p>
+          <a:p>
+            <a:pPr algn="l">
+              <a:spcAft>
+                <a:spcPts val="400"/>
+              </a:spcAft>
+            </a:pPr>
+          </a:p>
+          <a:p>
+            <a:pPr algn="l">
+              <a:spcAft>
+                <a:spcPts val="400"/>
+              </a:spcAft>
+            </a:pPr>
+            <a:r>
+              <a:rPr sz="1500" b="0">
+                <a:solidFill>
+                  <a:srgbClr val="202124"/>
+                </a:solidFill>
+                <a:latin typeface="Aptos"/>
+              </a:rPr>
+              <a:t>No se usaron datos simulados.</a:t>
+            </a:r>
+          </a:p>
+        </p:txBody>
+      </p:sp>
+      <p:sp>
+        <p:nvSpPr>
+          <p:cNvPr id="10" name="Rounded Rectangle 9"/>
+          <p:cNvSpPr/>
+          <p:nvPr/>
+        </p:nvSpPr>
+        <p:spPr>
+          <a:xfrm>
+            <a:off x="8074152" y="1325880"/>
+            <a:ext cx="3520440" cy="4434840"/>
+          </a:xfrm>
+          <a:prstGeom prst="roundRect">
+            <a:avLst/>
+          </a:prstGeom>
+          <a:solidFill>
+            <a:srgbClr val="F2F2F2"/>
+          </a:solidFill>
+          <a:ln w="12700">
+            <a:solidFill>
+              <a:srgbClr val="0B5394"/>
+            </a:solidFill>
+          </a:ln>
+        </p:spPr>
+        <p:style>
+          <a:lnRef idx="1">
+            <a:schemeClr val="accent1"/>
+          </a:lnRef>
+          <a:fillRef idx="3">
+            <a:schemeClr val="accent1"/>
+          </a:fillRef>
+          <a:effectRef idx="2">
+            <a:schemeClr val="accent1"/>
+          </a:effectRef>
+          <a:fontRef idx="minor">
+            <a:schemeClr val="lt1"/>
+          </a:fontRef>
+        </p:style>
+        <p:txBody>
+          <a:bodyPr rtlCol="0" anchor="ctr"/>
+          <a:lstStyle/>
+          <a:p>
+            <a:pPr algn="ctr"/>
+          </a:p>
+        </p:txBody>
+      </p:sp>
+      <p:sp>
+        <p:nvSpPr>
+          <p:cNvPr id="11" name="TextBox 10"/>
+          <p:cNvSpPr txBox="1"/>
+          <p:nvPr/>
+        </p:nvSpPr>
+        <p:spPr>
+          <a:xfrm>
+            <a:off x="8257031" y="1463039"/>
+            <a:ext cx="3154680" cy="292608"/>
+          </a:xfrm>
+          <a:prstGeom prst="rect">
+            <a:avLst/>
+          </a:prstGeom>
+          <a:noFill/>
+        </p:spPr>
+        <p:txBody>
+          <a:bodyPr wrap="square" anchor="t">
+            <a:spAutoFit/>
+          </a:bodyPr>
+          <a:lstStyle/>
+          <a:p>
+            <a:pPr algn="l">
+              <a:spcAft>
+                <a:spcPts val="400"/>
+              </a:spcAft>
+            </a:pPr>
+            <a:r>
+              <a:rPr sz="1000" b="1">
+                <a:solidFill>
+                  <a:srgbClr val="0B5394"/>
+                </a:solidFill>
+                <a:latin typeface="Aptos"/>
+              </a:rPr>
               <a:t>CÓMO SE DEMUESTRA</a:t>
             </a:r>
           </a:p>
@@ -6117,7 +6998,7 @@
                 </a:solidFill>
                 <a:latin typeface="Aptos"/>
               </a:rPr>
-              <a:t>Los títulos fueron contrastados contra las tablas del cuaderno.</a:t>
+              <a:t>Los títulos fueron contrastados contra las tablas del cuaderno. Los rendimientos reportados son en buena parte redondeados; la KDE es una aproximación suave.</a:t>
             </a:r>
           </a:p>
         </p:txBody>
@@ -7016,7 +7897,7 @@
                 </a:solidFill>
                 <a:latin typeface="Aptos"/>
               </a:rPr>
-              <a:t>Cundinamarca (20,0 t/ha) y Boyacá superan a Antioquia (14,0) y Nariño en mediana. Los cinco departamentos presentan dispersión amplia; el intervalo central del 95 % mide entre 22,0 y 37,0 t/ha.</a:t>
+              <a:t>Las medianas van de 14,0 t/ha (Antioquia) a 20,0 (Cundinamarca). Los cinco departamentos presentan dispersión amplia: el intervalo central del 95 % mide entre 22,0 y 37,0 t/ha.</a:t>
             </a:r>
           </a:p>
         </p:txBody>
@@ -9553,7 +10434,7 @@
                 </a:solidFill>
                 <a:latin typeface="Aptos"/>
               </a:rPr>
-              <a:t>Corte: maíz, yuca, frijol, tomate y plátano; N total = 51.959. Rendimiento normalizado por mediana nacional.</a:t>
+              <a:t>Corte: cinco cultivos con más registros EVA positivos; N total = 51.959. Rendimiento normalizado por mediana nacional.</a:t>
             </a:r>
           </a:p>
         </p:txBody>

</xml_diff>